<commit_message>
Swap slide 6 dashboard screenshot for the mobile view
The desktop screenshot left dead space in slide 6's card panel. Uses
a mobile-emulated capture instead (phone-width, full KPI grid visible)
resized to fill the panel's height as a floating phone card, which
fits the portrait panel shape much better.

Co-Authored-By: Claude Sonnet 5 <noreply@anthropic.com>
</commit_message>
<xml_diff>
--- a/mandate-ledger-demo.pptx
+++ b/mandate-ledger-demo.pptx
@@ -5354,8 +5354,8 @@
         </p:blipFill>
         <p:spPr>
           <a:xfrm>
-            <a:off x="7955280" y="2835712"/>
-            <a:ext cx="3703320" cy="2603896"/>
+            <a:off x="8774900" y="1941640"/>
+            <a:ext cx="2064000" cy="4392000"/>
           </a:xfrm>
           <a:prstGeom prst="rect">
             <a:avLst/>

</xml_diff>